<commit_message>
feat(security): implement Google Cloud Identity-Aware Proxy (IAP) with JWT verification, Terraform resources, and updated presentation slides
</commit_message>
<xml_diff>
--- a/docs/medquad_additional_slides.pptx
+++ b/docs/medquad_additional_slides.pptx
@@ -519,7 +519,7 @@
           <a:p/>
           <a:p>
             <a:r>
-              <a:t>1. Clinical Productivity: Literature review currently consumes hours of manual search across disparate medical databases. MedQuAD compresses this workflow from 45 minutes to under 7 seconds, saving an estimated 8.5 hours per clinician weekly.</a:t>
+              <a:t>1. Clinical Productivity: Literature review currently consumes 15 to 45 minutes of manual searching across PubMed and disparate medical repositories. MedQuAD compresses this investigation into a sub-7 second grounded synthesis, directly accelerating evidence-based decisions.</a:t>
             </a:r>
           </a:p>
           <a:p/>
@@ -801,7 +801,7 @@
           <a:p/>
           <a:p>
             <a:r>
-              <a:t>1. Perimeter Defense: Google Cloud Armor protects against DDoS and OWASP Top 10 attacks at the network edge, while Model Armor acts as an AI security guardrail, inspecting prompts for jailbreaks and prompt injections before reaching models.</a:t>
+              <a:t>1. Perimeter Defense &amp; Zero-Trust: Google Cloud Armor protects against DDoS and OWASP Top 10 attacks at the network edge, Google Identity-Aware Proxy (IAP) validates clinician identity via institutional SSO before traffic reaches the backend, and Model Armor inspects prompts for jailbreaks and scrubs PHI before reaching models.</a:t>
             </a:r>
           </a:p>
           <a:p/>
@@ -4178,7 +4178,7 @@
               </a:defRPr>
             </a:pPr>
             <a:r>
-              <a:t>85% Time Reduction</a:t>
+              <a:t>Sub-7s Latency</a:t>
             </a:r>
           </a:p>
           <a:p>
@@ -4194,7 +4194,7 @@
               </a:defRPr>
             </a:pPr>
             <a:r>
-              <a:t>Synthesis in &lt;7s vs 45m Manual Search</a:t>
+              <a:t>Instant Synthesis vs 15m+ Manual Search</a:t>
             </a:r>
           </a:p>
           <a:p>
@@ -4210,7 +4210,7 @@
               </a:defRPr>
             </a:pPr>
             <a:r>
-              <a:t>•  Replaces multi-tab PubMed manual searches with instant grounded synthesis.</a:t>
+              <a:t>•  Automates literature retrieval across 16,400+ peer-reviewed NIH medical documents.</a:t>
             </a:r>
           </a:p>
           <a:p>
@@ -4226,7 +4226,7 @@
               </a:defRPr>
             </a:pPr>
             <a:r>
-              <a:t>•  Saves ~8.5 hours weekly per clinician on medical literature investigation.</a:t>
+              <a:t>•  Compresses research turnaround from 15+ minutes to sub-7 second grounded synthesis.</a:t>
             </a:r>
           </a:p>
           <a:p>
@@ -4242,7 +4242,7 @@
               </a:defRPr>
             </a:pPr>
             <a:r>
-              <a:t>•  Accelerates clinical trial matching and evidence-based treatment decisions.</a:t>
+              <a:t>•  Accelerates evidence-based treatment inquiries and clinical literature reviews.</a:t>
             </a:r>
           </a:p>
         </p:txBody>
@@ -5778,7 +5778,7 @@
               </a:defRPr>
             </a:pPr>
             <a:r>
-              <a:t>Edge &amp; Input Security</a:t>
+              <a:t>WAF &amp; Zero-Trust SSO</a:t>
             </a:r>
           </a:p>
           <a:p>
@@ -5794,7 +5794,7 @@
               </a:defRPr>
             </a:pPr>
             <a:r>
-              <a:t>Cloud Armor &amp; Model Armor</a:t>
+              <a:t>Cloud Armor, IAP, &amp; Model Armor</a:t>
             </a:r>
           </a:p>
           <a:p>
@@ -5810,7 +5810,7 @@
               </a:defRPr>
             </a:pPr>
             <a:r>
-              <a:t>•  Cloud Armor blocks OWASP Top 10 vulnerabilities, DDoS, and bad actors at Google edge.</a:t>
+              <a:t>•  Cloud Armor blocks OWASP Top 10 vulnerabilities, DDoS, and bad actors at Google's edge.</a:t>
             </a:r>
           </a:p>
           <a:p>
@@ -5826,7 +5826,7 @@
               </a:defRPr>
             </a:pPr>
             <a:r>
-              <a:t>•  Model Armor intercepts adversarial prompt injections and jailbreaks before model invocation.</a:t>
+              <a:t>•  Identity-Aware Proxy (IAP) enforces institutional SSO and cryptographically validates JWT tokens.</a:t>
             </a:r>
           </a:p>
           <a:p>
@@ -5842,7 +5842,7 @@
               </a:defRPr>
             </a:pPr>
             <a:r>
-              <a:t>•  Input rate limiting and request length ceilings prevent denial-of-wallet attacks.</a:t>
+              <a:t>•  Model Armor intercepts adversarial prompt injections and sanitizes PHI before model invocation.</a:t>
             </a:r>
           </a:p>
         </p:txBody>

</xml_diff>